<commit_message>
powerpoint added to repo
</commit_message>
<xml_diff>
--- a/Capture the Password.pptx
+++ b/Capture the Password.pptx
@@ -879,7 +879,7 @@
     <p:bg>
       <p:bgPr>
         <a:solidFill>
-          <a:srgbClr val="0D1512"/>
+          <a:srgbClr val="112E23"/>
         </a:solidFill>
         <a:effectLst/>
       </p:bgPr>
@@ -1572,7 +1572,7 @@
                 <a:ea typeface="Arial" pitchFamily="34" charset="-122"/>
                 <a:cs typeface="Arial" pitchFamily="34" charset="-120"/>
               </a:rPr>
-              <a:t>Log in at </a:t>
+              <a:t>Look at </a:t>
             </a:r>
             <a:r>
               <a:rPr lang="en-US" sz="1700" dirty="0">
@@ -1583,18 +1583,40 @@
                 <a:ea typeface="Arial" pitchFamily="34" charset="-122"/>
                 <a:cs typeface="Arial" pitchFamily="34" charset="-120"/>
               </a:rPr>
-              <a:t>[your portal URL]</a:t>
+              <a:t>127.0.0.1:5500/</a:t>
+            </a:r>
+            <a:r>
+              <a:rPr lang="en-US" sz="1700" dirty="0" err="1">
+                <a:solidFill>
+                  <a:srgbClr val="58A6FF"/>
+                </a:solidFill>
+                <a:latin typeface="Arial" pitchFamily="34" charset="0"/>
+                <a:ea typeface="Arial" pitchFamily="34" charset="-122"/>
+                <a:cs typeface="Arial" pitchFamily="34" charset="-120"/>
+              </a:rPr>
+              <a:t>login.html</a:t>
             </a:r>
             <a:r>
               <a:rPr lang="en-US" sz="1700" dirty="0">
                 <a:solidFill>
+                  <a:srgbClr val="58A6FF"/>
+                </a:solidFill>
+                <a:latin typeface="Arial" pitchFamily="34" charset="0"/>
+                <a:ea typeface="Arial" pitchFamily="34" charset="-122"/>
+                <a:cs typeface="Arial" pitchFamily="34" charset="-120"/>
+              </a:rPr>
+              <a:t> </a:t>
+            </a:r>
+            <a:r>
+              <a:rPr lang="en-US" sz="1700" dirty="0">
+                <a:solidFill>
                   <a:srgbClr val="E6EDF3"/>
                 </a:solidFill>
                 <a:latin typeface="Arial" pitchFamily="34" charset="0"/>
                 <a:ea typeface="Arial" pitchFamily="34" charset="-122"/>
                 <a:cs typeface="Arial" pitchFamily="34" charset="-120"/>
               </a:rPr>
-              <a:t> — first team in wins.</a:t>
+              <a:t>— first team in wins.</a:t>
             </a:r>
             <a:endParaRPr lang="en-US" sz="1700" dirty="0"/>
           </a:p>
@@ -1602,10 +1624,10 @@
       </p:sp>
       <p:pic>
         <p:nvPicPr>
-          <p:cNvPr id="15" name="Graphic 14">
+          <p:cNvPr id="16" name="Picture 15">
             <a:extLst>
               <a:ext uri="{FF2B5EF4-FFF2-40B4-BE49-F238E27FC236}">
-                <a16:creationId xmlns:a16="http://schemas.microsoft.com/office/drawing/2014/main" id="{5F7D30F4-B34D-63E4-06EC-5C5B9AAD2757}"/>
+                <a16:creationId xmlns:a16="http://schemas.microsoft.com/office/drawing/2014/main" id="{7449A6CB-914B-DA3E-A92F-7A4930C81AA0}"/>
               </a:ext>
             </a:extLst>
           </p:cNvPr>
@@ -1615,21 +1637,15 @@
           <p:nvPr/>
         </p:nvPicPr>
         <p:blipFill>
-          <a:blip>
-            <a:extLst>
-              <a:ext uri="{96DAC541-7B7A-43D3-8B79-37D633B846F1}">
-                <asvg:svgBlip xmlns:asvg="http://schemas.microsoft.com/office/drawing/2016/SVG/main" r:embed="rId3"/>
-              </a:ext>
-            </a:extLst>
-          </a:blip>
+          <a:blip r:embed="rId3"/>
           <a:stretch>
             <a:fillRect/>
           </a:stretch>
         </p:blipFill>
         <p:spPr>
           <a:xfrm>
-            <a:off x="9218758" y="813368"/>
-            <a:ext cx="2466830" cy="2466830"/>
+            <a:off x="9145588" y="929216"/>
+            <a:ext cx="2540000" cy="2540000"/>
           </a:xfrm>
           <a:prstGeom prst="rect">
             <a:avLst/>

</xml_diff>